<commit_message>
Mettre à jour le rapport et la présentation finale
Co-Authored-By: Claude Opus 5.5 <noreply@anthropic.com>
</commit_message>
<xml_diff>
--- a/presentation/presentation_finale.pptx
+++ b/presentation/presentation_finale.pptx
@@ -1490,7 +1490,7 @@
           <a:p>
             <a:r>
               <a:rPr lang="en-US" dirty="0"/>
-              <a:t>[3:00] J'ai besoin d'un échantillon pour les nuages de points : 54 000 points se superposent. J'ai comparé cinq méthodes. Avec un seul tirage, toutes semblaient bonnes. Mais en répétant cent fois, on voit que les grappes de jours varient de 18 à 36 % : les retards dépendent énormément du jour. J'ai retenu l'échantillon stratifié par jour : 26,5 % de retard contre 26,2 % dans la population, et tous les jours représentés. Les pourcentages, eux, sont toujours calculés sur tous les vols.</a:t>
+              <a:t>[3:00] J'ai besoin d'un échantillon pour les nuages de points : 54 000 points se superposent. J'ai comparé sept méthodes, dont le bootstrap, qui tire avec remise, et le stratifié non proportionnel, qui prend le même nombre de vols par compagnie. Pour chaque échantillon, je calcule l'erreur absolue et l'erreur relative sur six indicateurs, et un score de représentativité : 100 moins l'erreur relative moyenne. Je répète chaque méthode cent fois. Les grappes sont instables, car les retards changent énormément d'un jour à l'autre. Le non proportionnel est dernier, c'est normal : Delta n'y fait plus que 12,5 % des vols ; si on le repondère, il retrouve la bonne valeur. J'ai retenu le stratifié par jour : dans le groupe de tête, et tous les jours sont représentés.</a:t>
             </a:r>
             <a:endParaRPr lang="en-US" dirty="0"/>
           </a:p>
@@ -1842,7 +1842,7 @@
           <a:p>
             <a:r>
               <a:rPr lang="en-US" dirty="0"/>
-              <a:t>[6:00] DÉMO (dashboard déjà ouvert dans le navigateur, tous les filtres par défaut). 1) Vue générale : je montre les 5 indicateurs, la courbe par heure, puis la carte jour × heure : plus c'est foncé, plus il y a de retard. 2) Dans les filtres, je règle l'heure de 18 h à 23 h : le pourcentage monte à environ 37 %, et l'indicateur affiche l'écart en rouge. Je remets 5 h – 23 h. 3) Onglet Effet domino : 24 % contre 50 %, et la courbe par heure. 4) Onglet Comparer : Delta contre Southwest, les courbes se séparent après 16 h. 5) Onglet Destinations : je survole Orlando pour montrer l'infobulle. Si la démo plante : les captures sont dans reports/captures.</a:t>
+              <a:t>[6:00] DÉMO (dashboard déjà ouvert dans le navigateur, tous les filtres par défaut). 1) Vue générale : je montre les 5 indicateurs, la courbe par heure, puis la carte jour × heure : plus c'est foncé, plus il y a de retard. 2) Dans les filtres, je règle l'heure de 18 h à 23 h : le pourcentage monte à environ 37 %, et l'indicateur affiche l'écart en rouge. Je remets 5 h – 23 h. 3) Onglet Effet domino : 24 % contre 50 %, et la courbe par heure. 4) Onglet Comparer : Delta contre Southwest, les courbes se séparent après 16 h. 5) Onglet Échantillonnage : je choisis Bootstrap, on voit les lignes en double et le score ; je descends jusqu'au classement des méthodes. (Si le temps le permet : onglet Qualité des données.) Si la démo plante : les captures sont dans reports/captures.</a:t>
             </a:r>
             <a:endParaRPr lang="en-US" dirty="0"/>
           </a:p>
@@ -6333,7 +6333,7 @@
                 <a:ea typeface="Calibri" pitchFamily="34" charset="-122"/>
                 <a:cs typeface="Calibri" pitchFamily="34" charset="-120"/>
               </a:rPr>
-              <a:t>Échantillonnage : un seul tirage peut tromper</a:t>
+              <a:t>Échantillonnage : 7 méthodes, un classement</a:t>
             </a:r>
             <a:endParaRPr lang="en-US" sz="2800" dirty="0"/>
           </a:p>
@@ -6372,7 +6372,7 @@
                 <a:ea typeface="Calibri" pitchFamily="34" charset="-122"/>
                 <a:cs typeface="Calibri" pitchFamily="34" charset="-120"/>
               </a:rPr>
-              <a:t>5 méthodes, 5 000 vols (10 %), chacune répétée 100 fois — pour des nuages de points lisibles</a:t>
+              <a:t>5 000 vols · erreurs absolue et relative · score de représentativité · 100 tirages par méthode</a:t>
             </a:r>
             <a:endParaRPr lang="en-US" sz="1400" dirty="0"/>
           </a:p>
@@ -6394,7 +6394,7 @@
         <p:spPr>
           <a:xfrm>
             <a:off x="365760" y="1280160"/>
-            <a:ext cx="5212080" cy="2331720"/>
+            <a:ext cx="4846320" cy="2377440"/>
           </a:xfrm>
           <a:prstGeom prst="rect">
             <a:avLst/>
@@ -6416,18 +6416,19 @@
           </p:nvPr>
         </p:nvGraphicFramePr>
         <p:xfrm>
-          <a:off x="5806440" y="1325880"/>
-          <a:ext cx="2880360" cy="914400"/>
+          <a:off x="5394960" y="1280160"/>
+          <a:ext cx="3291840" cy="914400"/>
         </p:xfrm>
         <a:graphic>
           <a:graphicData uri="http://schemas.openxmlformats.org/drawingml/2006/table">
             <a:tbl>
               <a:tblPr/>
               <a:tblGrid>
-                <a:gridCol w="1920240"/>
-                <a:gridCol w="960120"/>
+                <a:gridCol w="320040"/>
+                <a:gridCol w="2240280"/>
+                <a:gridCol w="731520"/>
               </a:tblGrid>
-              <a:tr h="329184">
+              <a:tr h="292608">
                 <a:tc>
                   <a:txBody>
                     <a:bodyPr/>
@@ -6437,7 +6438,7 @@
                         <a:buNone/>
                       </a:pPr>
                       <a:r>
-                        <a:rPr lang="en-US" sz="1100" b="1" dirty="0">
+                        <a:rPr lang="en-US" sz="1050" b="1" dirty="0">
                           <a:solidFill>
                             <a:srgbClr val="FFFFFF"/>
                           </a:solidFill>
@@ -6445,16 +6446,16 @@
                           <a:ea typeface="Calibri" pitchFamily="34" charset="-122"/>
                           <a:cs typeface="Calibri" pitchFamily="34" charset="-120"/>
                         </a:rPr>
-                        <a:t>Méthode</a:t>
+                        <a:t>#</a:t>
                       </a:r>
-                      <a:endParaRPr lang="en-US" sz="1100" dirty="0">
+                      <a:endParaRPr lang="en-US" sz="1050" dirty="0">
                         <a:latin typeface="Calibri" charset="0"/>
                         <a:ea typeface="Calibri" charset="0"/>
                         <a:cs typeface="Calibri" charset="0"/>
                       </a:endParaRPr>
                     </a:p>
                   </a:txBody>
-                  <a:tcPr marL="54864" marR="54864" marT="54864" marB="54864" anchor="ctr">
+                  <a:tcPr marL="45720" marR="45720" marT="45720" marB="45720" anchor="ctr">
                     <a:lnL w="6350" cap="flat" cmpd="sng" algn="ctr">
                       <a:solidFill>
                         <a:srgbClr val="E1E0D9"/>
@@ -6505,7 +6506,7 @@
                         <a:buNone/>
                       </a:pPr>
                       <a:r>
-                        <a:rPr lang="en-US" sz="1100" b="1" dirty="0">
+                        <a:rPr lang="en-US" sz="1050" b="1" dirty="0">
                           <a:solidFill>
                             <a:srgbClr val="FFFFFF"/>
                           </a:solidFill>
@@ -6513,16 +6514,84 @@
                           <a:ea typeface="Calibri" pitchFamily="34" charset="-122"/>
                           <a:cs typeface="Calibri" pitchFamily="34" charset="-120"/>
                         </a:rPr>
-                        <a:t>Écart-type</a:t>
+                        <a:t>Méthode</a:t>
                       </a:r>
-                      <a:endParaRPr lang="en-US" sz="1100" dirty="0">
+                      <a:endParaRPr lang="en-US" sz="1050" dirty="0">
                         <a:latin typeface="Calibri" charset="0"/>
                         <a:ea typeface="Calibri" charset="0"/>
                         <a:cs typeface="Calibri" charset="0"/>
                       </a:endParaRPr>
                     </a:p>
                   </a:txBody>
-                  <a:tcPr marL="54864" marR="54864" marT="54864" marB="54864" anchor="ctr">
+                  <a:tcPr marL="45720" marR="45720" marT="45720" marB="45720" anchor="ctr">
+                    <a:lnL w="6350" cap="flat" cmpd="sng" algn="ctr">
+                      <a:solidFill>
+                        <a:srgbClr val="E1E0D9"/>
+                      </a:solidFill>
+                      <a:prstDash val="solid"/>
+                      <a:round/>
+                      <a:headEnd type="none" w="med" len="med"/>
+                      <a:tailEnd type="none" w="med" len="med"/>
+                    </a:lnL>
+                    <a:lnR w="6350" cap="flat" cmpd="sng" algn="ctr">
+                      <a:solidFill>
+                        <a:srgbClr val="E1E0D9"/>
+                      </a:solidFill>
+                      <a:prstDash val="solid"/>
+                      <a:round/>
+                      <a:headEnd type="none" w="med" len="med"/>
+                      <a:tailEnd type="none" w="med" len="med"/>
+                    </a:lnR>
+                    <a:lnT w="6350" cap="flat" cmpd="sng" algn="ctr">
+                      <a:solidFill>
+                        <a:srgbClr val="E1E0D9"/>
+                      </a:solidFill>
+                      <a:prstDash val="solid"/>
+                      <a:round/>
+                      <a:headEnd type="none" w="med" len="med"/>
+                      <a:tailEnd type="none" w="med" len="med"/>
+                    </a:lnT>
+                    <a:lnB w="6350" cap="flat" cmpd="sng" algn="ctr">
+                      <a:solidFill>
+                        <a:srgbClr val="E1E0D9"/>
+                      </a:solidFill>
+                      <a:prstDash val="solid"/>
+                      <a:round/>
+                      <a:headEnd type="none" w="med" len="med"/>
+                      <a:tailEnd type="none" w="med" len="med"/>
+                    </a:lnB>
+                    <a:solidFill>
+                      <a:srgbClr val="14213D"/>
+                    </a:solidFill>
+                  </a:tcPr>
+                </a:tc>
+                <a:tc>
+                  <a:txBody>
+                    <a:bodyPr/>
+                    <a:lstStyle/>
+                    <a:p>
+                      <a:pPr indent="0" marL="0">
+                        <a:buNone/>
+                      </a:pPr>
+                      <a:r>
+                        <a:rPr lang="en-US" sz="1050" b="1" dirty="0">
+                          <a:solidFill>
+                            <a:srgbClr val="FFFFFF"/>
+                          </a:solidFill>
+                          <a:latin typeface="Calibri" pitchFamily="34" charset="0"/>
+                          <a:ea typeface="Calibri" pitchFamily="34" charset="-122"/>
+                          <a:cs typeface="Calibri" pitchFamily="34" charset="-120"/>
+                        </a:rPr>
+                        <a:t>Score</a:t>
+                      </a:r>
+                      <a:endParaRPr lang="en-US" sz="1050" dirty="0">
+                        <a:latin typeface="Calibri" charset="0"/>
+                        <a:ea typeface="Calibri" charset="0"/>
+                        <a:cs typeface="Calibri" charset="0"/>
+                      </a:endParaRPr>
+                    </a:p>
+                  </a:txBody>
+                  <a:tcPr marL="45720" marR="45720" marT="45720" marB="45720" anchor="ctr">
                     <a:lnL w="6350" cap="flat" cmpd="sng" algn="ctr">
                       <a:solidFill>
                         <a:srgbClr val="E1E0D9"/>
@@ -6565,7 +6634,7 @@
                   </a:tcPr>
                 </a:tc>
               </a:tr>
-              <a:tr h="329184">
+              <a:tr h="292608">
                 <a:tc>
                   <a:txBody>
                     <a:bodyPr/>
@@ -6575,7 +6644,7 @@
                         <a:buNone/>
                       </a:pPr>
                       <a:r>
-                        <a:rPr lang="en-US" sz="1100" dirty="0">
+                        <a:rPr lang="en-US" sz="1050" dirty="0">
                           <a:solidFill>
                             <a:srgbClr val="1F2937"/>
                           </a:solidFill>
@@ -6583,16 +6652,16 @@
                           <a:ea typeface="Calibri" pitchFamily="34" charset="-122"/>
                           <a:cs typeface="Calibri" pitchFamily="34" charset="-120"/>
                         </a:rPr>
-                        <a:t>Aléatoire simple</a:t>
+                        <a:t>1</a:t>
                       </a:r>
-                      <a:endParaRPr lang="en-US" sz="1100" dirty="0">
+                      <a:endParaRPr lang="en-US" sz="1050" dirty="0">
                         <a:latin typeface="Calibri" charset="0"/>
                         <a:ea typeface="Calibri" charset="0"/>
                         <a:cs typeface="Calibri" charset="0"/>
                       </a:endParaRPr>
                     </a:p>
                   </a:txBody>
-                  <a:tcPr marL="54864" marR="54864" marT="54864" marB="54864" anchor="ctr">
+                  <a:tcPr marL="45720" marR="45720" marT="45720" marB="45720" anchor="ctr">
                     <a:lnL w="6350" cap="flat" cmpd="sng" algn="ctr">
                       <a:solidFill>
                         <a:srgbClr val="E1E0D9"/>
@@ -6640,74 +6709,7 @@
                         <a:buNone/>
                       </a:pPr>
                       <a:r>
-                        <a:rPr lang="en-US" sz="1100" dirty="0">
-                          <a:solidFill>
-                            <a:srgbClr val="1F2937"/>
-                          </a:solidFill>
-                          <a:latin typeface="Calibri" pitchFamily="34" charset="0"/>
-                          <a:ea typeface="Calibri" pitchFamily="34" charset="-122"/>
-                          <a:cs typeface="Calibri" pitchFamily="34" charset="-120"/>
-                        </a:rPr>
-                        <a:t>0,55 pt</a:t>
-                      </a:r>
-                      <a:endParaRPr lang="en-US" sz="1100" dirty="0">
-                        <a:latin typeface="Calibri" charset="0"/>
-                        <a:ea typeface="Calibri" charset="0"/>
-                        <a:cs typeface="Calibri" charset="0"/>
-                      </a:endParaRPr>
-                    </a:p>
-                  </a:txBody>
-                  <a:tcPr marL="54864" marR="54864" marT="54864" marB="54864" anchor="ctr">
-                    <a:lnL w="6350" cap="flat" cmpd="sng" algn="ctr">
-                      <a:solidFill>
-                        <a:srgbClr val="E1E0D9"/>
-                      </a:solidFill>
-                      <a:prstDash val="solid"/>
-                      <a:round/>
-                      <a:headEnd type="none" w="med" len="med"/>
-                      <a:tailEnd type="none" w="med" len="med"/>
-                    </a:lnL>
-                    <a:lnR w="6350" cap="flat" cmpd="sng" algn="ctr">
-                      <a:solidFill>
-                        <a:srgbClr val="E1E0D9"/>
-                      </a:solidFill>
-                      <a:prstDash val="solid"/>
-                      <a:round/>
-                      <a:headEnd type="none" w="med" len="med"/>
-                      <a:tailEnd type="none" w="med" len="med"/>
-                    </a:lnR>
-                    <a:lnT w="6350" cap="flat" cmpd="sng" algn="ctr">
-                      <a:solidFill>
-                        <a:srgbClr val="E1E0D9"/>
-                      </a:solidFill>
-                      <a:prstDash val="solid"/>
-                      <a:round/>
-                      <a:headEnd type="none" w="med" len="med"/>
-                      <a:tailEnd type="none" w="med" len="med"/>
-                    </a:lnT>
-                    <a:lnB w="6350" cap="flat" cmpd="sng" algn="ctr">
-                      <a:solidFill>
-                        <a:srgbClr val="E1E0D9"/>
-                      </a:solidFill>
-                      <a:prstDash val="solid"/>
-                      <a:round/>
-                      <a:headEnd type="none" w="med" len="med"/>
-                      <a:tailEnd type="none" w="med" len="med"/>
-                    </a:lnB>
-                  </a:tcPr>
-                </a:tc>
-              </a:tr>
-              <a:tr h="329184">
-                <a:tc>
-                  <a:txBody>
-                    <a:bodyPr/>
-                    <a:lstStyle/>
-                    <a:p>
-                      <a:pPr indent="0" marL="0">
-                        <a:buNone/>
-                      </a:pPr>
-                      <a:r>
-                        <a:rPr lang="en-US" sz="1100" dirty="0">
+                        <a:rPr lang="en-US" sz="1050" dirty="0">
                           <a:solidFill>
                             <a:srgbClr val="1F2937"/>
                           </a:solidFill>
@@ -6717,14 +6719,14 @@
                         </a:rPr>
                         <a:t>Systématique</a:t>
                       </a:r>
-                      <a:endParaRPr lang="en-US" sz="1100" dirty="0">
+                      <a:endParaRPr lang="en-US" sz="1050" dirty="0">
                         <a:latin typeface="Calibri" charset="0"/>
                         <a:ea typeface="Calibri" charset="0"/>
                         <a:cs typeface="Calibri" charset="0"/>
                       </a:endParaRPr>
                     </a:p>
                   </a:txBody>
-                  <a:tcPr marL="54864" marR="54864" marT="54864" marB="54864" anchor="ctr">
+                  <a:tcPr marL="45720" marR="45720" marT="45720" marB="45720" anchor="ctr">
                     <a:lnL w="6350" cap="flat" cmpd="sng" algn="ctr">
                       <a:solidFill>
                         <a:srgbClr val="E1E0D9"/>
@@ -6772,7 +6774,7 @@
                         <a:buNone/>
                       </a:pPr>
                       <a:r>
-                        <a:rPr lang="en-US" sz="1100" dirty="0">
+                        <a:rPr lang="en-US" sz="1050" dirty="0">
                           <a:solidFill>
                             <a:srgbClr val="1F2937"/>
                           </a:solidFill>
@@ -6780,16 +6782,16 @@
                           <a:ea typeface="Calibri" pitchFamily="34" charset="-122"/>
                           <a:cs typeface="Calibri" pitchFamily="34" charset="-120"/>
                         </a:rPr>
-                        <a:t>0,53 pt</a:t>
+                        <a:t>96,7</a:t>
                       </a:r>
-                      <a:endParaRPr lang="en-US" sz="1100" dirty="0">
+                      <a:endParaRPr lang="en-US" sz="1050" dirty="0">
                         <a:latin typeface="Calibri" charset="0"/>
                         <a:ea typeface="Calibri" charset="0"/>
                         <a:cs typeface="Calibri" charset="0"/>
                       </a:endParaRPr>
                     </a:p>
                   </a:txBody>
-                  <a:tcPr marL="54864" marR="54864" marT="54864" marB="54864" anchor="ctr">
+                  <a:tcPr marL="45720" marR="45720" marT="45720" marB="45720" anchor="ctr">
                     <a:lnL w="6350" cap="flat" cmpd="sng" algn="ctr">
                       <a:solidFill>
                         <a:srgbClr val="E1E0D9"/>
@@ -6829,7 +6831,7 @@
                   </a:tcPr>
                 </a:tc>
               </a:tr>
-              <a:tr h="329184">
+              <a:tr h="292608">
                 <a:tc>
                   <a:txBody>
                     <a:bodyPr/>
@@ -6839,7 +6841,7 @@
                         <a:buNone/>
                       </a:pPr>
                       <a:r>
-                        <a:rPr lang="en-US" sz="1100" dirty="0">
+                        <a:rPr lang="en-US" sz="1050" dirty="0">
                           <a:solidFill>
                             <a:srgbClr val="1F2937"/>
                           </a:solidFill>
@@ -6847,16 +6849,16 @@
                           <a:ea typeface="Calibri" pitchFamily="34" charset="-122"/>
                           <a:cs typeface="Calibri" pitchFamily="34" charset="-120"/>
                         </a:rPr>
-                        <a:t>Stratifié (compagnie)</a:t>
+                        <a:t>2</a:t>
                       </a:r>
-                      <a:endParaRPr lang="en-US" sz="1100" dirty="0">
+                      <a:endParaRPr lang="en-US" sz="1050" dirty="0">
                         <a:latin typeface="Calibri" charset="0"/>
                         <a:ea typeface="Calibri" charset="0"/>
                         <a:cs typeface="Calibri" charset="0"/>
                       </a:endParaRPr>
                     </a:p>
                   </a:txBody>
-                  <a:tcPr marL="54864" marR="54864" marT="54864" marB="54864" anchor="ctr">
+                  <a:tcPr marL="45720" marR="45720" marT="45720" marB="45720" anchor="ctr">
                     <a:lnL w="6350" cap="flat" cmpd="sng" algn="ctr">
                       <a:solidFill>
                         <a:srgbClr val="E1E0D9"/>
@@ -6904,7 +6906,7 @@
                         <a:buNone/>
                       </a:pPr>
                       <a:r>
-                        <a:rPr lang="en-US" sz="1100" dirty="0">
+                        <a:rPr lang="en-US" sz="1050" dirty="0">
                           <a:solidFill>
                             <a:srgbClr val="1F2937"/>
                           </a:solidFill>
@@ -6912,83 +6914,16 @@
                           <a:ea typeface="Calibri" pitchFamily="34" charset="-122"/>
                           <a:cs typeface="Calibri" pitchFamily="34" charset="-120"/>
                         </a:rPr>
-                        <a:t>0,60 pt</a:t>
+                        <a:t>Stratifié (compagnie)</a:t>
                       </a:r>
-                      <a:endParaRPr lang="en-US" sz="1100" dirty="0">
+                      <a:endParaRPr lang="en-US" sz="1050" dirty="0">
                         <a:latin typeface="Calibri" charset="0"/>
                         <a:ea typeface="Calibri" charset="0"/>
                         <a:cs typeface="Calibri" charset="0"/>
                       </a:endParaRPr>
                     </a:p>
                   </a:txBody>
-                  <a:tcPr marL="54864" marR="54864" marT="54864" marB="54864" anchor="ctr">
-                    <a:lnL w="6350" cap="flat" cmpd="sng" algn="ctr">
-                      <a:solidFill>
-                        <a:srgbClr val="E1E0D9"/>
-                      </a:solidFill>
-                      <a:prstDash val="solid"/>
-                      <a:round/>
-                      <a:headEnd type="none" w="med" len="med"/>
-                      <a:tailEnd type="none" w="med" len="med"/>
-                    </a:lnL>
-                    <a:lnR w="6350" cap="flat" cmpd="sng" algn="ctr">
-                      <a:solidFill>
-                        <a:srgbClr val="E1E0D9"/>
-                      </a:solidFill>
-                      <a:prstDash val="solid"/>
-                      <a:round/>
-                      <a:headEnd type="none" w="med" len="med"/>
-                      <a:tailEnd type="none" w="med" len="med"/>
-                    </a:lnR>
-                    <a:lnT w="6350" cap="flat" cmpd="sng" algn="ctr">
-                      <a:solidFill>
-                        <a:srgbClr val="E1E0D9"/>
-                      </a:solidFill>
-                      <a:prstDash val="solid"/>
-                      <a:round/>
-                      <a:headEnd type="none" w="med" len="med"/>
-                      <a:tailEnd type="none" w="med" len="med"/>
-                    </a:lnT>
-                    <a:lnB w="6350" cap="flat" cmpd="sng" algn="ctr">
-                      <a:solidFill>
-                        <a:srgbClr val="E1E0D9"/>
-                      </a:solidFill>
-                      <a:prstDash val="solid"/>
-                      <a:round/>
-                      <a:headEnd type="none" w="med" len="med"/>
-                      <a:tailEnd type="none" w="med" len="med"/>
-                    </a:lnB>
-                  </a:tcPr>
-                </a:tc>
-              </a:tr>
-              <a:tr h="329184">
-                <a:tc>
-                  <a:txBody>
-                    <a:bodyPr/>
-                    <a:lstStyle/>
-                    <a:p>
-                      <a:pPr indent="0" marL="0">
-                        <a:buNone/>
-                      </a:pPr>
-                      <a:r>
-                        <a:rPr lang="en-US" sz="1100" b="1" dirty="0">
-                          <a:solidFill>
-                            <a:srgbClr val="EB6834"/>
-                          </a:solidFill>
-                          <a:latin typeface="Calibri" pitchFamily="34" charset="0"/>
-                          <a:ea typeface="Calibri" pitchFamily="34" charset="-122"/>
-                          <a:cs typeface="Calibri" pitchFamily="34" charset="-120"/>
-                        </a:rPr>
-                        <a:t>Par grappes (jours)</a:t>
-                      </a:r>
-                      <a:endParaRPr lang="en-US" sz="1100" dirty="0">
-                        <a:latin typeface="Calibri" charset="0"/>
-                        <a:ea typeface="Calibri" charset="0"/>
-                        <a:cs typeface="Calibri" charset="0"/>
-                      </a:endParaRPr>
-                    </a:p>
-                  </a:txBody>
-                  <a:tcPr marL="54864" marR="54864" marT="54864" marB="54864" anchor="ctr">
+                  <a:tcPr marL="45720" marR="45720" marT="45720" marB="45720" anchor="ctr">
                     <a:lnL w="6350" cap="flat" cmpd="sng" algn="ctr">
                       <a:solidFill>
                         <a:srgbClr val="E1E0D9"/>
@@ -7036,24 +6971,24 @@
                         <a:buNone/>
                       </a:pPr>
                       <a:r>
-                        <a:rPr lang="en-US" sz="1100" b="1" dirty="0">
+                        <a:rPr lang="en-US" sz="1050" dirty="0">
                           <a:solidFill>
-                            <a:srgbClr val="EB6834"/>
+                            <a:srgbClr val="1F2937"/>
                           </a:solidFill>
                           <a:latin typeface="Calibri" pitchFamily="34" charset="0"/>
                           <a:ea typeface="Calibri" pitchFamily="34" charset="-122"/>
                           <a:cs typeface="Calibri" pitchFamily="34" charset="-120"/>
                         </a:rPr>
-                        <a:t>3,92 pts</a:t>
+                        <a:t>96,1</a:t>
                       </a:r>
-                      <a:endParaRPr lang="en-US" sz="1100" dirty="0">
+                      <a:endParaRPr lang="en-US" sz="1050" dirty="0">
                         <a:latin typeface="Calibri" charset="0"/>
                         <a:ea typeface="Calibri" charset="0"/>
                         <a:cs typeface="Calibri" charset="0"/>
                       </a:endParaRPr>
                     </a:p>
                   </a:txBody>
-                  <a:tcPr marL="54864" marR="54864" marT="54864" marB="54864" anchor="ctr">
+                  <a:tcPr marL="45720" marR="45720" marT="45720" marB="45720" anchor="ctr">
                     <a:lnL w="6350" cap="flat" cmpd="sng" algn="ctr">
                       <a:solidFill>
                         <a:srgbClr val="E1E0D9"/>
@@ -7093,7 +7028,7 @@
                   </a:tcPr>
                 </a:tc>
               </a:tr>
-              <a:tr h="329184">
+              <a:tr h="292608">
                 <a:tc>
                   <a:txBody>
                     <a:bodyPr/>
@@ -7103,7 +7038,7 @@
                         <a:buNone/>
                       </a:pPr>
                       <a:r>
-                        <a:rPr lang="en-US" sz="1100" b="1" dirty="0">
+                        <a:rPr lang="en-US" sz="1050" b="1" dirty="0">
                           <a:solidFill>
                             <a:srgbClr val="1F2937"/>
                           </a:solidFill>
@@ -7111,16 +7046,16 @@
                           <a:ea typeface="Calibri" pitchFamily="34" charset="-122"/>
                           <a:cs typeface="Calibri" pitchFamily="34" charset="-120"/>
                         </a:rPr>
-                        <a:t>Stratifié par jour ✔</a:t>
+                        <a:t>3</a:t>
                       </a:r>
-                      <a:endParaRPr lang="en-US" sz="1100" dirty="0">
+                      <a:endParaRPr lang="en-US" sz="1050" dirty="0">
                         <a:latin typeface="Calibri" charset="0"/>
                         <a:ea typeface="Calibri" charset="0"/>
                         <a:cs typeface="Calibri" charset="0"/>
                       </a:endParaRPr>
                     </a:p>
                   </a:txBody>
-                  <a:tcPr marL="54864" marR="54864" marT="54864" marB="54864" anchor="ctr">
+                  <a:tcPr marL="45720" marR="45720" marT="45720" marB="45720" anchor="ctr">
                     <a:lnL w="6350" cap="flat" cmpd="sng" algn="ctr">
                       <a:solidFill>
                         <a:srgbClr val="E1E0D9"/>
@@ -7171,7 +7106,7 @@
                         <a:buNone/>
                       </a:pPr>
                       <a:r>
-                        <a:rPr lang="en-US" sz="1100" b="1" dirty="0">
+                        <a:rPr lang="en-US" sz="1050" b="1" dirty="0">
                           <a:solidFill>
                             <a:srgbClr val="1F2937"/>
                           </a:solidFill>
@@ -7179,16 +7114,84 @@
                           <a:ea typeface="Calibri" pitchFamily="34" charset="-122"/>
                           <a:cs typeface="Calibri" pitchFamily="34" charset="-120"/>
                         </a:rPr>
-                        <a:t>0,52 pt</a:t>
+                        <a:t>Stratifié par jour ✔</a:t>
                       </a:r>
-                      <a:endParaRPr lang="en-US" sz="1100" dirty="0">
+                      <a:endParaRPr lang="en-US" sz="1050" dirty="0">
                         <a:latin typeface="Calibri" charset="0"/>
                         <a:ea typeface="Calibri" charset="0"/>
                         <a:cs typeface="Calibri" charset="0"/>
                       </a:endParaRPr>
                     </a:p>
                   </a:txBody>
-                  <a:tcPr marL="54864" marR="54864" marT="54864" marB="54864" anchor="ctr">
+                  <a:tcPr marL="45720" marR="45720" marT="45720" marB="45720" anchor="ctr">
+                    <a:lnL w="6350" cap="flat" cmpd="sng" algn="ctr">
+                      <a:solidFill>
+                        <a:srgbClr val="E1E0D9"/>
+                      </a:solidFill>
+                      <a:prstDash val="solid"/>
+                      <a:round/>
+                      <a:headEnd type="none" w="med" len="med"/>
+                      <a:tailEnd type="none" w="med" len="med"/>
+                    </a:lnL>
+                    <a:lnR w="6350" cap="flat" cmpd="sng" algn="ctr">
+                      <a:solidFill>
+                        <a:srgbClr val="E1E0D9"/>
+                      </a:solidFill>
+                      <a:prstDash val="solid"/>
+                      <a:round/>
+                      <a:headEnd type="none" w="med" len="med"/>
+                      <a:tailEnd type="none" w="med" len="med"/>
+                    </a:lnR>
+                    <a:lnT w="6350" cap="flat" cmpd="sng" algn="ctr">
+                      <a:solidFill>
+                        <a:srgbClr val="E1E0D9"/>
+                      </a:solidFill>
+                      <a:prstDash val="solid"/>
+                      <a:round/>
+                      <a:headEnd type="none" w="med" len="med"/>
+                      <a:tailEnd type="none" w="med" len="med"/>
+                    </a:lnT>
+                    <a:lnB w="6350" cap="flat" cmpd="sng" algn="ctr">
+                      <a:solidFill>
+                        <a:srgbClr val="E1E0D9"/>
+                      </a:solidFill>
+                      <a:prstDash val="solid"/>
+                      <a:round/>
+                      <a:headEnd type="none" w="med" len="med"/>
+                      <a:tailEnd type="none" w="med" len="med"/>
+                    </a:lnB>
+                    <a:solidFill>
+                      <a:srgbClr val="FDEEE7"/>
+                    </a:solidFill>
+                  </a:tcPr>
+                </a:tc>
+                <a:tc>
+                  <a:txBody>
+                    <a:bodyPr/>
+                    <a:lstStyle/>
+                    <a:p>
+                      <a:pPr indent="0" marL="0">
+                        <a:buNone/>
+                      </a:pPr>
+                      <a:r>
+                        <a:rPr lang="en-US" sz="1050" b="1" dirty="0">
+                          <a:solidFill>
+                            <a:srgbClr val="1F2937"/>
+                          </a:solidFill>
+                          <a:latin typeface="Calibri" pitchFamily="34" charset="0"/>
+                          <a:ea typeface="Calibri" pitchFamily="34" charset="-122"/>
+                          <a:cs typeface="Calibri" pitchFamily="34" charset="-120"/>
+                        </a:rPr>
+                        <a:t>96,0</a:t>
+                      </a:r>
+                      <a:endParaRPr lang="en-US" sz="1050" dirty="0">
+                        <a:latin typeface="Calibri" charset="0"/>
+                        <a:ea typeface="Calibri" charset="0"/>
+                        <a:cs typeface="Calibri" charset="0"/>
+                      </a:endParaRPr>
+                    </a:p>
+                  </a:txBody>
+                  <a:tcPr marL="45720" marR="45720" marT="45720" marB="45720" anchor="ctr">
                     <a:lnL w="6350" cap="flat" cmpd="sng" algn="ctr">
                       <a:solidFill>
                         <a:srgbClr val="E1E0D9"/>
@@ -7231,6 +7234,794 @@
                   </a:tcPr>
                 </a:tc>
               </a:tr>
+              <a:tr h="292608">
+                <a:tc>
+                  <a:txBody>
+                    <a:bodyPr/>
+                    <a:lstStyle/>
+                    <a:p>
+                      <a:pPr indent="0" marL="0">
+                        <a:buNone/>
+                      </a:pPr>
+                      <a:r>
+                        <a:rPr lang="en-US" sz="1050" dirty="0">
+                          <a:solidFill>
+                            <a:srgbClr val="1F2937"/>
+                          </a:solidFill>
+                          <a:latin typeface="Calibri" pitchFamily="34" charset="0"/>
+                          <a:ea typeface="Calibri" pitchFamily="34" charset="-122"/>
+                          <a:cs typeface="Calibri" pitchFamily="34" charset="-120"/>
+                        </a:rPr>
+                        <a:t>4</a:t>
+                      </a:r>
+                      <a:endParaRPr lang="en-US" sz="1050" dirty="0">
+                        <a:latin typeface="Calibri" charset="0"/>
+                        <a:ea typeface="Calibri" charset="0"/>
+                        <a:cs typeface="Calibri" charset="0"/>
+                      </a:endParaRPr>
+                    </a:p>
+                  </a:txBody>
+                  <a:tcPr marL="45720" marR="45720" marT="45720" marB="45720" anchor="ctr">
+                    <a:lnL w="6350" cap="flat" cmpd="sng" algn="ctr">
+                      <a:solidFill>
+                        <a:srgbClr val="E1E0D9"/>
+                      </a:solidFill>
+                      <a:prstDash val="solid"/>
+                      <a:round/>
+                      <a:headEnd type="none" w="med" len="med"/>
+                      <a:tailEnd type="none" w="med" len="med"/>
+                    </a:lnL>
+                    <a:lnR w="6350" cap="flat" cmpd="sng" algn="ctr">
+                      <a:solidFill>
+                        <a:srgbClr val="E1E0D9"/>
+                      </a:solidFill>
+                      <a:prstDash val="solid"/>
+                      <a:round/>
+                      <a:headEnd type="none" w="med" len="med"/>
+                      <a:tailEnd type="none" w="med" len="med"/>
+                    </a:lnR>
+                    <a:lnT w="6350" cap="flat" cmpd="sng" algn="ctr">
+                      <a:solidFill>
+                        <a:srgbClr val="E1E0D9"/>
+                      </a:solidFill>
+                      <a:prstDash val="solid"/>
+                      <a:round/>
+                      <a:headEnd type="none" w="med" len="med"/>
+                      <a:tailEnd type="none" w="med" len="med"/>
+                    </a:lnT>
+                    <a:lnB w="6350" cap="flat" cmpd="sng" algn="ctr">
+                      <a:solidFill>
+                        <a:srgbClr val="E1E0D9"/>
+                      </a:solidFill>
+                      <a:prstDash val="solid"/>
+                      <a:round/>
+                      <a:headEnd type="none" w="med" len="med"/>
+                      <a:tailEnd type="none" w="med" len="med"/>
+                    </a:lnB>
+                  </a:tcPr>
+                </a:tc>
+                <a:tc>
+                  <a:txBody>
+                    <a:bodyPr/>
+                    <a:lstStyle/>
+                    <a:p>
+                      <a:pPr indent="0" marL="0">
+                        <a:buNone/>
+                      </a:pPr>
+                      <a:r>
+                        <a:rPr lang="en-US" sz="1050" dirty="0">
+                          <a:solidFill>
+                            <a:srgbClr val="1F2937"/>
+                          </a:solidFill>
+                          <a:latin typeface="Calibri" pitchFamily="34" charset="0"/>
+                          <a:ea typeface="Calibri" pitchFamily="34" charset="-122"/>
+                          <a:cs typeface="Calibri" pitchFamily="34" charset="-120"/>
+                        </a:rPr>
+                        <a:t>Aléatoire simple</a:t>
+                      </a:r>
+                      <a:endParaRPr lang="en-US" sz="1050" dirty="0">
+                        <a:latin typeface="Calibri" charset="0"/>
+                        <a:ea typeface="Calibri" charset="0"/>
+                        <a:cs typeface="Calibri" charset="0"/>
+                      </a:endParaRPr>
+                    </a:p>
+                  </a:txBody>
+                  <a:tcPr marL="45720" marR="45720" marT="45720" marB="45720" anchor="ctr">
+                    <a:lnL w="6350" cap="flat" cmpd="sng" algn="ctr">
+                      <a:solidFill>
+                        <a:srgbClr val="E1E0D9"/>
+                      </a:solidFill>
+                      <a:prstDash val="solid"/>
+                      <a:round/>
+                      <a:headEnd type="none" w="med" len="med"/>
+                      <a:tailEnd type="none" w="med" len="med"/>
+                    </a:lnL>
+                    <a:lnR w="6350" cap="flat" cmpd="sng" algn="ctr">
+                      <a:solidFill>
+                        <a:srgbClr val="E1E0D9"/>
+                      </a:solidFill>
+                      <a:prstDash val="solid"/>
+                      <a:round/>
+                      <a:headEnd type="none" w="med" len="med"/>
+                      <a:tailEnd type="none" w="med" len="med"/>
+                    </a:lnR>
+                    <a:lnT w="6350" cap="flat" cmpd="sng" algn="ctr">
+                      <a:solidFill>
+                        <a:srgbClr val="E1E0D9"/>
+                      </a:solidFill>
+                      <a:prstDash val="solid"/>
+                      <a:round/>
+                      <a:headEnd type="none" w="med" len="med"/>
+                      <a:tailEnd type="none" w="med" len="med"/>
+                    </a:lnT>
+                    <a:lnB w="6350" cap="flat" cmpd="sng" algn="ctr">
+                      <a:solidFill>
+                        <a:srgbClr val="E1E0D9"/>
+                      </a:solidFill>
+                      <a:prstDash val="solid"/>
+                      <a:round/>
+                      <a:headEnd type="none" w="med" len="med"/>
+                      <a:tailEnd type="none" w="med" len="med"/>
+                    </a:lnB>
+                  </a:tcPr>
+                </a:tc>
+                <a:tc>
+                  <a:txBody>
+                    <a:bodyPr/>
+                    <a:lstStyle/>
+                    <a:p>
+                      <a:pPr indent="0" marL="0">
+                        <a:buNone/>
+                      </a:pPr>
+                      <a:r>
+                        <a:rPr lang="en-US" sz="1050" dirty="0">
+                          <a:solidFill>
+                            <a:srgbClr val="1F2937"/>
+                          </a:solidFill>
+                          <a:latin typeface="Calibri" pitchFamily="34" charset="0"/>
+                          <a:ea typeface="Calibri" pitchFamily="34" charset="-122"/>
+                          <a:cs typeface="Calibri" pitchFamily="34" charset="-120"/>
+                        </a:rPr>
+                        <a:t>95,8</a:t>
+                      </a:r>
+                      <a:endParaRPr lang="en-US" sz="1050" dirty="0">
+                        <a:latin typeface="Calibri" charset="0"/>
+                        <a:ea typeface="Calibri" charset="0"/>
+                        <a:cs typeface="Calibri" charset="0"/>
+                      </a:endParaRPr>
+                    </a:p>
+                  </a:txBody>
+                  <a:tcPr marL="45720" marR="45720" marT="45720" marB="45720" anchor="ctr">
+                    <a:lnL w="6350" cap="flat" cmpd="sng" algn="ctr">
+                      <a:solidFill>
+                        <a:srgbClr val="E1E0D9"/>
+                      </a:solidFill>
+                      <a:prstDash val="solid"/>
+                      <a:round/>
+                      <a:headEnd type="none" w="med" len="med"/>
+                      <a:tailEnd type="none" w="med" len="med"/>
+                    </a:lnL>
+                    <a:lnR w="6350" cap="flat" cmpd="sng" algn="ctr">
+                      <a:solidFill>
+                        <a:srgbClr val="E1E0D9"/>
+                      </a:solidFill>
+                      <a:prstDash val="solid"/>
+                      <a:round/>
+                      <a:headEnd type="none" w="med" len="med"/>
+                      <a:tailEnd type="none" w="med" len="med"/>
+                    </a:lnR>
+                    <a:lnT w="6350" cap="flat" cmpd="sng" algn="ctr">
+                      <a:solidFill>
+                        <a:srgbClr val="E1E0D9"/>
+                      </a:solidFill>
+                      <a:prstDash val="solid"/>
+                      <a:round/>
+                      <a:headEnd type="none" w="med" len="med"/>
+                      <a:tailEnd type="none" w="med" len="med"/>
+                    </a:lnT>
+                    <a:lnB w="6350" cap="flat" cmpd="sng" algn="ctr">
+                      <a:solidFill>
+                        <a:srgbClr val="E1E0D9"/>
+                      </a:solidFill>
+                      <a:prstDash val="solid"/>
+                      <a:round/>
+                      <a:headEnd type="none" w="med" len="med"/>
+                      <a:tailEnd type="none" w="med" len="med"/>
+                    </a:lnB>
+                  </a:tcPr>
+                </a:tc>
+              </a:tr>
+              <a:tr h="292608">
+                <a:tc>
+                  <a:txBody>
+                    <a:bodyPr/>
+                    <a:lstStyle/>
+                    <a:p>
+                      <a:pPr indent="0" marL="0">
+                        <a:buNone/>
+                      </a:pPr>
+                      <a:r>
+                        <a:rPr lang="en-US" sz="1050" dirty="0">
+                          <a:solidFill>
+                            <a:srgbClr val="1F2937"/>
+                          </a:solidFill>
+                          <a:latin typeface="Calibri" pitchFamily="34" charset="0"/>
+                          <a:ea typeface="Calibri" pitchFamily="34" charset="-122"/>
+                          <a:cs typeface="Calibri" pitchFamily="34" charset="-120"/>
+                        </a:rPr>
+                        <a:t>5</a:t>
+                      </a:r>
+                      <a:endParaRPr lang="en-US" sz="1050" dirty="0">
+                        <a:latin typeface="Calibri" charset="0"/>
+                        <a:ea typeface="Calibri" charset="0"/>
+                        <a:cs typeface="Calibri" charset="0"/>
+                      </a:endParaRPr>
+                    </a:p>
+                  </a:txBody>
+                  <a:tcPr marL="45720" marR="45720" marT="45720" marB="45720" anchor="ctr">
+                    <a:lnL w="6350" cap="flat" cmpd="sng" algn="ctr">
+                      <a:solidFill>
+                        <a:srgbClr val="E1E0D9"/>
+                      </a:solidFill>
+                      <a:prstDash val="solid"/>
+                      <a:round/>
+                      <a:headEnd type="none" w="med" len="med"/>
+                      <a:tailEnd type="none" w="med" len="med"/>
+                    </a:lnL>
+                    <a:lnR w="6350" cap="flat" cmpd="sng" algn="ctr">
+                      <a:solidFill>
+                        <a:srgbClr val="E1E0D9"/>
+                      </a:solidFill>
+                      <a:prstDash val="solid"/>
+                      <a:round/>
+                      <a:headEnd type="none" w="med" len="med"/>
+                      <a:tailEnd type="none" w="med" len="med"/>
+                    </a:lnR>
+                    <a:lnT w="6350" cap="flat" cmpd="sng" algn="ctr">
+                      <a:solidFill>
+                        <a:srgbClr val="E1E0D9"/>
+                      </a:solidFill>
+                      <a:prstDash val="solid"/>
+                      <a:round/>
+                      <a:headEnd type="none" w="med" len="med"/>
+                      <a:tailEnd type="none" w="med" len="med"/>
+                    </a:lnT>
+                    <a:lnB w="6350" cap="flat" cmpd="sng" algn="ctr">
+                      <a:solidFill>
+                        <a:srgbClr val="E1E0D9"/>
+                      </a:solidFill>
+                      <a:prstDash val="solid"/>
+                      <a:round/>
+                      <a:headEnd type="none" w="med" len="med"/>
+                      <a:tailEnd type="none" w="med" len="med"/>
+                    </a:lnB>
+                  </a:tcPr>
+                </a:tc>
+                <a:tc>
+                  <a:txBody>
+                    <a:bodyPr/>
+                    <a:lstStyle/>
+                    <a:p>
+                      <a:pPr indent="0" marL="0">
+                        <a:buNone/>
+                      </a:pPr>
+                      <a:r>
+                        <a:rPr lang="en-US" sz="1050" dirty="0">
+                          <a:solidFill>
+                            <a:srgbClr val="1F2937"/>
+                          </a:solidFill>
+                          <a:latin typeface="Calibri" pitchFamily="34" charset="0"/>
+                          <a:ea typeface="Calibri" pitchFamily="34" charset="-122"/>
+                          <a:cs typeface="Calibri" pitchFamily="34" charset="-120"/>
+                        </a:rPr>
+                        <a:t>Bootstrap (avec remise)</a:t>
+                      </a:r>
+                      <a:endParaRPr lang="en-US" sz="1050" dirty="0">
+                        <a:latin typeface="Calibri" charset="0"/>
+                        <a:ea typeface="Calibri" charset="0"/>
+                        <a:cs typeface="Calibri" charset="0"/>
+                      </a:endParaRPr>
+                    </a:p>
+                  </a:txBody>
+                  <a:tcPr marL="45720" marR="45720" marT="45720" marB="45720" anchor="ctr">
+                    <a:lnL w="6350" cap="flat" cmpd="sng" algn="ctr">
+                      <a:solidFill>
+                        <a:srgbClr val="E1E0D9"/>
+                      </a:solidFill>
+                      <a:prstDash val="solid"/>
+                      <a:round/>
+                      <a:headEnd type="none" w="med" len="med"/>
+                      <a:tailEnd type="none" w="med" len="med"/>
+                    </a:lnL>
+                    <a:lnR w="6350" cap="flat" cmpd="sng" algn="ctr">
+                      <a:solidFill>
+                        <a:srgbClr val="E1E0D9"/>
+                      </a:solidFill>
+                      <a:prstDash val="solid"/>
+                      <a:round/>
+                      <a:headEnd type="none" w="med" len="med"/>
+                      <a:tailEnd type="none" w="med" len="med"/>
+                    </a:lnR>
+                    <a:lnT w="6350" cap="flat" cmpd="sng" algn="ctr">
+                      <a:solidFill>
+                        <a:srgbClr val="E1E0D9"/>
+                      </a:solidFill>
+                      <a:prstDash val="solid"/>
+                      <a:round/>
+                      <a:headEnd type="none" w="med" len="med"/>
+                      <a:tailEnd type="none" w="med" len="med"/>
+                    </a:lnT>
+                    <a:lnB w="6350" cap="flat" cmpd="sng" algn="ctr">
+                      <a:solidFill>
+                        <a:srgbClr val="E1E0D9"/>
+                      </a:solidFill>
+                      <a:prstDash val="solid"/>
+                      <a:round/>
+                      <a:headEnd type="none" w="med" len="med"/>
+                      <a:tailEnd type="none" w="med" len="med"/>
+                    </a:lnB>
+                  </a:tcPr>
+                </a:tc>
+                <a:tc>
+                  <a:txBody>
+                    <a:bodyPr/>
+                    <a:lstStyle/>
+                    <a:p>
+                      <a:pPr indent="0" marL="0">
+                        <a:buNone/>
+                      </a:pPr>
+                      <a:r>
+                        <a:rPr lang="en-US" sz="1050" dirty="0">
+                          <a:solidFill>
+                            <a:srgbClr val="1F2937"/>
+                          </a:solidFill>
+                          <a:latin typeface="Calibri" pitchFamily="34" charset="0"/>
+                          <a:ea typeface="Calibri" pitchFamily="34" charset="-122"/>
+                          <a:cs typeface="Calibri" pitchFamily="34" charset="-120"/>
+                        </a:rPr>
+                        <a:t>95,7</a:t>
+                      </a:r>
+                      <a:endParaRPr lang="en-US" sz="1050" dirty="0">
+                        <a:latin typeface="Calibri" charset="0"/>
+                        <a:ea typeface="Calibri" charset="0"/>
+                        <a:cs typeface="Calibri" charset="0"/>
+                      </a:endParaRPr>
+                    </a:p>
+                  </a:txBody>
+                  <a:tcPr marL="45720" marR="45720" marT="45720" marB="45720" anchor="ctr">
+                    <a:lnL w="6350" cap="flat" cmpd="sng" algn="ctr">
+                      <a:solidFill>
+                        <a:srgbClr val="E1E0D9"/>
+                      </a:solidFill>
+                      <a:prstDash val="solid"/>
+                      <a:round/>
+                      <a:headEnd type="none" w="med" len="med"/>
+                      <a:tailEnd type="none" w="med" len="med"/>
+                    </a:lnL>
+                    <a:lnR w="6350" cap="flat" cmpd="sng" algn="ctr">
+                      <a:solidFill>
+                        <a:srgbClr val="E1E0D9"/>
+                      </a:solidFill>
+                      <a:prstDash val="solid"/>
+                      <a:round/>
+                      <a:headEnd type="none" w="med" len="med"/>
+                      <a:tailEnd type="none" w="med" len="med"/>
+                    </a:lnR>
+                    <a:lnT w="6350" cap="flat" cmpd="sng" algn="ctr">
+                      <a:solidFill>
+                        <a:srgbClr val="E1E0D9"/>
+                      </a:solidFill>
+                      <a:prstDash val="solid"/>
+                      <a:round/>
+                      <a:headEnd type="none" w="med" len="med"/>
+                      <a:tailEnd type="none" w="med" len="med"/>
+                    </a:lnT>
+                    <a:lnB w="6350" cap="flat" cmpd="sng" algn="ctr">
+                      <a:solidFill>
+                        <a:srgbClr val="E1E0D9"/>
+                      </a:solidFill>
+                      <a:prstDash val="solid"/>
+                      <a:round/>
+                      <a:headEnd type="none" w="med" len="med"/>
+                      <a:tailEnd type="none" w="med" len="med"/>
+                    </a:lnB>
+                  </a:tcPr>
+                </a:tc>
+              </a:tr>
+              <a:tr h="292608">
+                <a:tc>
+                  <a:txBody>
+                    <a:bodyPr/>
+                    <a:lstStyle/>
+                    <a:p>
+                      <a:pPr indent="0" marL="0">
+                        <a:buNone/>
+                      </a:pPr>
+                      <a:r>
+                        <a:rPr lang="en-US" sz="1050" b="1" dirty="0">
+                          <a:solidFill>
+                            <a:srgbClr val="EB6834"/>
+                          </a:solidFill>
+                          <a:latin typeface="Calibri" pitchFamily="34" charset="0"/>
+                          <a:ea typeface="Calibri" pitchFamily="34" charset="-122"/>
+                          <a:cs typeface="Calibri" pitchFamily="34" charset="-120"/>
+                        </a:rPr>
+                        <a:t>6</a:t>
+                      </a:r>
+                      <a:endParaRPr lang="en-US" sz="1050" dirty="0">
+                        <a:latin typeface="Calibri" charset="0"/>
+                        <a:ea typeface="Calibri" charset="0"/>
+                        <a:cs typeface="Calibri" charset="0"/>
+                      </a:endParaRPr>
+                    </a:p>
+                  </a:txBody>
+                  <a:tcPr marL="45720" marR="45720" marT="45720" marB="45720" anchor="ctr">
+                    <a:lnL w="6350" cap="flat" cmpd="sng" algn="ctr">
+                      <a:solidFill>
+                        <a:srgbClr val="E1E0D9"/>
+                      </a:solidFill>
+                      <a:prstDash val="solid"/>
+                      <a:round/>
+                      <a:headEnd type="none" w="med" len="med"/>
+                      <a:tailEnd type="none" w="med" len="med"/>
+                    </a:lnL>
+                    <a:lnR w="6350" cap="flat" cmpd="sng" algn="ctr">
+                      <a:solidFill>
+                        <a:srgbClr val="E1E0D9"/>
+                      </a:solidFill>
+                      <a:prstDash val="solid"/>
+                      <a:round/>
+                      <a:headEnd type="none" w="med" len="med"/>
+                      <a:tailEnd type="none" w="med" len="med"/>
+                    </a:lnR>
+                    <a:lnT w="6350" cap="flat" cmpd="sng" algn="ctr">
+                      <a:solidFill>
+                        <a:srgbClr val="E1E0D9"/>
+                      </a:solidFill>
+                      <a:prstDash val="solid"/>
+                      <a:round/>
+                      <a:headEnd type="none" w="med" len="med"/>
+                      <a:tailEnd type="none" w="med" len="med"/>
+                    </a:lnT>
+                    <a:lnB w="6350" cap="flat" cmpd="sng" algn="ctr">
+                      <a:solidFill>
+                        <a:srgbClr val="E1E0D9"/>
+                      </a:solidFill>
+                      <a:prstDash val="solid"/>
+                      <a:round/>
+                      <a:headEnd type="none" w="med" len="med"/>
+                      <a:tailEnd type="none" w="med" len="med"/>
+                    </a:lnB>
+                  </a:tcPr>
+                </a:tc>
+                <a:tc>
+                  <a:txBody>
+                    <a:bodyPr/>
+                    <a:lstStyle/>
+                    <a:p>
+                      <a:pPr indent="0" marL="0">
+                        <a:buNone/>
+                      </a:pPr>
+                      <a:r>
+                        <a:rPr lang="en-US" sz="1050" b="1" dirty="0">
+                          <a:solidFill>
+                            <a:srgbClr val="EB6834"/>
+                          </a:solidFill>
+                          <a:latin typeface="Calibri" pitchFamily="34" charset="0"/>
+                          <a:ea typeface="Calibri" pitchFamily="34" charset="-122"/>
+                          <a:cs typeface="Calibri" pitchFamily="34" charset="-120"/>
+                        </a:rPr>
+                        <a:t>Par grappes (jours)</a:t>
+                      </a:r>
+                      <a:endParaRPr lang="en-US" sz="1050" dirty="0">
+                        <a:latin typeface="Calibri" charset="0"/>
+                        <a:ea typeface="Calibri" charset="0"/>
+                        <a:cs typeface="Calibri" charset="0"/>
+                      </a:endParaRPr>
+                    </a:p>
+                  </a:txBody>
+                  <a:tcPr marL="45720" marR="45720" marT="45720" marB="45720" anchor="ctr">
+                    <a:lnL w="6350" cap="flat" cmpd="sng" algn="ctr">
+                      <a:solidFill>
+                        <a:srgbClr val="E1E0D9"/>
+                      </a:solidFill>
+                      <a:prstDash val="solid"/>
+                      <a:round/>
+                      <a:headEnd type="none" w="med" len="med"/>
+                      <a:tailEnd type="none" w="med" len="med"/>
+                    </a:lnL>
+                    <a:lnR w="6350" cap="flat" cmpd="sng" algn="ctr">
+                      <a:solidFill>
+                        <a:srgbClr val="E1E0D9"/>
+                      </a:solidFill>
+                      <a:prstDash val="solid"/>
+                      <a:round/>
+                      <a:headEnd type="none" w="med" len="med"/>
+                      <a:tailEnd type="none" w="med" len="med"/>
+                    </a:lnR>
+                    <a:lnT w="6350" cap="flat" cmpd="sng" algn="ctr">
+                      <a:solidFill>
+                        <a:srgbClr val="E1E0D9"/>
+                      </a:solidFill>
+                      <a:prstDash val="solid"/>
+                      <a:round/>
+                      <a:headEnd type="none" w="med" len="med"/>
+                      <a:tailEnd type="none" w="med" len="med"/>
+                    </a:lnT>
+                    <a:lnB w="6350" cap="flat" cmpd="sng" algn="ctr">
+                      <a:solidFill>
+                        <a:srgbClr val="E1E0D9"/>
+                      </a:solidFill>
+                      <a:prstDash val="solid"/>
+                      <a:round/>
+                      <a:headEnd type="none" w="med" len="med"/>
+                      <a:tailEnd type="none" w="med" len="med"/>
+                    </a:lnB>
+                  </a:tcPr>
+                </a:tc>
+                <a:tc>
+                  <a:txBody>
+                    <a:bodyPr/>
+                    <a:lstStyle/>
+                    <a:p>
+                      <a:pPr indent="0" marL="0">
+                        <a:buNone/>
+                      </a:pPr>
+                      <a:r>
+                        <a:rPr lang="en-US" sz="1050" b="1" dirty="0">
+                          <a:solidFill>
+                            <a:srgbClr val="EB6834"/>
+                          </a:solidFill>
+                          <a:latin typeface="Calibri" pitchFamily="34" charset="0"/>
+                          <a:ea typeface="Calibri" pitchFamily="34" charset="-122"/>
+                          <a:cs typeface="Calibri" pitchFamily="34" charset="-120"/>
+                        </a:rPr>
+                        <a:t>84,8</a:t>
+                      </a:r>
+                      <a:endParaRPr lang="en-US" sz="1050" dirty="0">
+                        <a:latin typeface="Calibri" charset="0"/>
+                        <a:ea typeface="Calibri" charset="0"/>
+                        <a:cs typeface="Calibri" charset="0"/>
+                      </a:endParaRPr>
+                    </a:p>
+                  </a:txBody>
+                  <a:tcPr marL="45720" marR="45720" marT="45720" marB="45720" anchor="ctr">
+                    <a:lnL w="6350" cap="flat" cmpd="sng" algn="ctr">
+                      <a:solidFill>
+                        <a:srgbClr val="E1E0D9"/>
+                      </a:solidFill>
+                      <a:prstDash val="solid"/>
+                      <a:round/>
+                      <a:headEnd type="none" w="med" len="med"/>
+                      <a:tailEnd type="none" w="med" len="med"/>
+                    </a:lnL>
+                    <a:lnR w="6350" cap="flat" cmpd="sng" algn="ctr">
+                      <a:solidFill>
+                        <a:srgbClr val="E1E0D9"/>
+                      </a:solidFill>
+                      <a:prstDash val="solid"/>
+                      <a:round/>
+                      <a:headEnd type="none" w="med" len="med"/>
+                      <a:tailEnd type="none" w="med" len="med"/>
+                    </a:lnR>
+                    <a:lnT w="6350" cap="flat" cmpd="sng" algn="ctr">
+                      <a:solidFill>
+                        <a:srgbClr val="E1E0D9"/>
+                      </a:solidFill>
+                      <a:prstDash val="solid"/>
+                      <a:round/>
+                      <a:headEnd type="none" w="med" len="med"/>
+                      <a:tailEnd type="none" w="med" len="med"/>
+                    </a:lnT>
+                    <a:lnB w="6350" cap="flat" cmpd="sng" algn="ctr">
+                      <a:solidFill>
+                        <a:srgbClr val="E1E0D9"/>
+                      </a:solidFill>
+                      <a:prstDash val="solid"/>
+                      <a:round/>
+                      <a:headEnd type="none" w="med" len="med"/>
+                      <a:tailEnd type="none" w="med" len="med"/>
+                    </a:lnB>
+                  </a:tcPr>
+                </a:tc>
+              </a:tr>
+              <a:tr h="292608">
+                <a:tc>
+                  <a:txBody>
+                    <a:bodyPr/>
+                    <a:lstStyle/>
+                    <a:p>
+                      <a:pPr indent="0" marL="0">
+                        <a:buNone/>
+                      </a:pPr>
+                      <a:r>
+                        <a:rPr lang="en-US" sz="1050" b="1" dirty="0">
+                          <a:solidFill>
+                            <a:srgbClr val="EB6834"/>
+                          </a:solidFill>
+                          <a:latin typeface="Calibri" pitchFamily="34" charset="0"/>
+                          <a:ea typeface="Calibri" pitchFamily="34" charset="-122"/>
+                          <a:cs typeface="Calibri" pitchFamily="34" charset="-120"/>
+                        </a:rPr>
+                        <a:t>7</a:t>
+                      </a:r>
+                      <a:endParaRPr lang="en-US" sz="1050" dirty="0">
+                        <a:latin typeface="Calibri" charset="0"/>
+                        <a:ea typeface="Calibri" charset="0"/>
+                        <a:cs typeface="Calibri" charset="0"/>
+                      </a:endParaRPr>
+                    </a:p>
+                  </a:txBody>
+                  <a:tcPr marL="45720" marR="45720" marT="45720" marB="45720" anchor="ctr">
+                    <a:lnL w="6350" cap="flat" cmpd="sng" algn="ctr">
+                      <a:solidFill>
+                        <a:srgbClr val="E1E0D9"/>
+                      </a:solidFill>
+                      <a:prstDash val="solid"/>
+                      <a:round/>
+                      <a:headEnd type="none" w="med" len="med"/>
+                      <a:tailEnd type="none" w="med" len="med"/>
+                    </a:lnL>
+                    <a:lnR w="6350" cap="flat" cmpd="sng" algn="ctr">
+                      <a:solidFill>
+                        <a:srgbClr val="E1E0D9"/>
+                      </a:solidFill>
+                      <a:prstDash val="solid"/>
+                      <a:round/>
+                      <a:headEnd type="none" w="med" len="med"/>
+                      <a:tailEnd type="none" w="med" len="med"/>
+                    </a:lnR>
+                    <a:lnT w="6350" cap="flat" cmpd="sng" algn="ctr">
+                      <a:solidFill>
+                        <a:srgbClr val="E1E0D9"/>
+                      </a:solidFill>
+                      <a:prstDash val="solid"/>
+                      <a:round/>
+                      <a:headEnd type="none" w="med" len="med"/>
+                      <a:tailEnd type="none" w="med" len="med"/>
+                    </a:lnT>
+                    <a:lnB w="6350" cap="flat" cmpd="sng" algn="ctr">
+                      <a:solidFill>
+                        <a:srgbClr val="E1E0D9"/>
+                      </a:solidFill>
+                      <a:prstDash val="solid"/>
+                      <a:round/>
+                      <a:headEnd type="none" w="med" len="med"/>
+                      <a:tailEnd type="none" w="med" len="med"/>
+                    </a:lnB>
+                  </a:tcPr>
+                </a:tc>
+                <a:tc>
+                  <a:txBody>
+                    <a:bodyPr/>
+                    <a:lstStyle/>
+                    <a:p>
+                      <a:pPr indent="0" marL="0">
+                        <a:buNone/>
+                      </a:pPr>
+                      <a:r>
+                        <a:rPr lang="en-US" sz="1050" b="1" dirty="0">
+                          <a:solidFill>
+                            <a:srgbClr val="EB6834"/>
+                          </a:solidFill>
+                          <a:latin typeface="Calibri" pitchFamily="34" charset="0"/>
+                          <a:ea typeface="Calibri" pitchFamily="34" charset="-122"/>
+                          <a:cs typeface="Calibri" pitchFamily="34" charset="-120"/>
+                        </a:rPr>
+                        <a:t>Stratifié non proportionnel</a:t>
+                      </a:r>
+                      <a:endParaRPr lang="en-US" sz="1050" dirty="0">
+                        <a:latin typeface="Calibri" charset="0"/>
+                        <a:ea typeface="Calibri" charset="0"/>
+                        <a:cs typeface="Calibri" charset="0"/>
+                      </a:endParaRPr>
+                    </a:p>
+                  </a:txBody>
+                  <a:tcPr marL="45720" marR="45720" marT="45720" marB="45720" anchor="ctr">
+                    <a:lnL w="6350" cap="flat" cmpd="sng" algn="ctr">
+                      <a:solidFill>
+                        <a:srgbClr val="E1E0D9"/>
+                      </a:solidFill>
+                      <a:prstDash val="solid"/>
+                      <a:round/>
+                      <a:headEnd type="none" w="med" len="med"/>
+                      <a:tailEnd type="none" w="med" len="med"/>
+                    </a:lnL>
+                    <a:lnR w="6350" cap="flat" cmpd="sng" algn="ctr">
+                      <a:solidFill>
+                        <a:srgbClr val="E1E0D9"/>
+                      </a:solidFill>
+                      <a:prstDash val="solid"/>
+                      <a:round/>
+                      <a:headEnd type="none" w="med" len="med"/>
+                      <a:tailEnd type="none" w="med" len="med"/>
+                    </a:lnR>
+                    <a:lnT w="6350" cap="flat" cmpd="sng" algn="ctr">
+                      <a:solidFill>
+                        <a:srgbClr val="E1E0D9"/>
+                      </a:solidFill>
+                      <a:prstDash val="solid"/>
+                      <a:round/>
+                      <a:headEnd type="none" w="med" len="med"/>
+                      <a:tailEnd type="none" w="med" len="med"/>
+                    </a:lnT>
+                    <a:lnB w="6350" cap="flat" cmpd="sng" algn="ctr">
+                      <a:solidFill>
+                        <a:srgbClr val="E1E0D9"/>
+                      </a:solidFill>
+                      <a:prstDash val="solid"/>
+                      <a:round/>
+                      <a:headEnd type="none" w="med" len="med"/>
+                      <a:tailEnd type="none" w="med" len="med"/>
+                    </a:lnB>
+                  </a:tcPr>
+                </a:tc>
+                <a:tc>
+                  <a:txBody>
+                    <a:bodyPr/>
+                    <a:lstStyle/>
+                    <a:p>
+                      <a:pPr indent="0" marL="0">
+                        <a:buNone/>
+                      </a:pPr>
+                      <a:r>
+                        <a:rPr lang="en-US" sz="1050" b="1" dirty="0">
+                          <a:solidFill>
+                            <a:srgbClr val="EB6834"/>
+                          </a:solidFill>
+                          <a:latin typeface="Calibri" pitchFamily="34" charset="0"/>
+                          <a:ea typeface="Calibri" pitchFamily="34" charset="-122"/>
+                          <a:cs typeface="Calibri" pitchFamily="34" charset="-120"/>
+                        </a:rPr>
+                        <a:t>71,8</a:t>
+                      </a:r>
+                      <a:endParaRPr lang="en-US" sz="1050" dirty="0">
+                        <a:latin typeface="Calibri" charset="0"/>
+                        <a:ea typeface="Calibri" charset="0"/>
+                        <a:cs typeface="Calibri" charset="0"/>
+                      </a:endParaRPr>
+                    </a:p>
+                  </a:txBody>
+                  <a:tcPr marL="45720" marR="45720" marT="45720" marB="45720" anchor="ctr">
+                    <a:lnL w="6350" cap="flat" cmpd="sng" algn="ctr">
+                      <a:solidFill>
+                        <a:srgbClr val="E1E0D9"/>
+                      </a:solidFill>
+                      <a:prstDash val="solid"/>
+                      <a:round/>
+                      <a:headEnd type="none" w="med" len="med"/>
+                      <a:tailEnd type="none" w="med" len="med"/>
+                    </a:lnL>
+                    <a:lnR w="6350" cap="flat" cmpd="sng" algn="ctr">
+                      <a:solidFill>
+                        <a:srgbClr val="E1E0D9"/>
+                      </a:solidFill>
+                      <a:prstDash val="solid"/>
+                      <a:round/>
+                      <a:headEnd type="none" w="med" len="med"/>
+                      <a:tailEnd type="none" w="med" len="med"/>
+                    </a:lnR>
+                    <a:lnT w="6350" cap="flat" cmpd="sng" algn="ctr">
+                      <a:solidFill>
+                        <a:srgbClr val="E1E0D9"/>
+                      </a:solidFill>
+                      <a:prstDash val="solid"/>
+                      <a:round/>
+                      <a:headEnd type="none" w="med" len="med"/>
+                      <a:tailEnd type="none" w="med" len="med"/>
+                    </a:lnT>
+                    <a:lnB w="6350" cap="flat" cmpd="sng" algn="ctr">
+                      <a:solidFill>
+                        <a:srgbClr val="E1E0D9"/>
+                      </a:solidFill>
+                      <a:prstDash val="solid"/>
+                      <a:round/>
+                      <a:headEnd type="none" w="med" len="med"/>
+                      <a:tailEnd type="none" w="med" len="med"/>
+                    </a:lnB>
+                  </a:tcPr>
+                </a:tc>
+              </a:tr>
             </a:tbl>
           </a:graphicData>
         </a:graphic>
@@ -7244,7 +8035,7 @@
         <p:spPr>
           <a:xfrm>
             <a:off x="457200" y="3840480"/>
-            <a:ext cx="8229600" cy="777240"/>
+            <a:ext cx="8229600" cy="822960"/>
           </a:xfrm>
           <a:prstGeom prst="rect">
             <a:avLst/>
@@ -7260,7 +8051,63 @@
               <a:buNone/>
             </a:pPr>
             <a:r>
-              <a:rPr lang="en-US" sz="1300" dirty="0">
+              <a:rPr lang="en-US" sz="1200" b="1" dirty="0">
+                <a:solidFill>
+                  <a:srgbClr val="EB6834"/>
+                </a:solidFill>
+                <a:latin typeface="Calibri" pitchFamily="34" charset="0"/>
+                <a:ea typeface="Calibri" pitchFamily="34" charset="-122"/>
+                <a:cs typeface="Calibri" pitchFamily="34" charset="-120"/>
+              </a:rPr>
+              <a:t>Grappes instables : </a:t>
+            </a:r>
+            <a:pPr indent="0" marL="0">
+              <a:buNone/>
+            </a:pPr>
+            <a:r>
+              <a:rPr lang="en-US" sz="1200" dirty="0">
+                <a:solidFill>
+                  <a:srgbClr val="1F2937"/>
+                </a:solidFill>
+                <a:latin typeface="Calibri" pitchFamily="34" charset="0"/>
+                <a:ea typeface="Calibri" pitchFamily="34" charset="-122"/>
+                <a:cs typeface="Calibri" pitchFamily="34" charset="-120"/>
+              </a:rPr>
+              <a:t>les retards varient énormément d'un jour à l'autre (10 % → 63 %). </a:t>
+            </a:r>
+            <a:pPr indent="0" marL="0">
+              <a:buNone/>
+            </a:pPr>
+            <a:r>
+              <a:rPr lang="en-US" sz="1200" b="1" dirty="0">
+                <a:solidFill>
+                  <a:srgbClr val="EB6834"/>
+                </a:solidFill>
+                <a:latin typeface="Calibri" pitchFamily="34" charset="0"/>
+                <a:ea typeface="Calibri" pitchFamily="34" charset="-122"/>
+                <a:cs typeface="Calibri" pitchFamily="34" charset="-120"/>
+              </a:rPr>
+              <a:t>Non proportionnel biaisé : </a:t>
+            </a:r>
+            <a:pPr indent="0" marL="0">
+              <a:buNone/>
+            </a:pPr>
+            <a:r>
+              <a:rPr lang="en-US" sz="1200" dirty="0">
+                <a:solidFill>
+                  <a:srgbClr val="1F2937"/>
+                </a:solidFill>
+                <a:latin typeface="Calibri" pitchFamily="34" charset="0"/>
+                <a:ea typeface="Calibri" pitchFamily="34" charset="-122"/>
+                <a:cs typeface="Calibri" pitchFamily="34" charset="-120"/>
+              </a:rPr>
+              <a:t>Delta passe de 66 % à 12,5 % ; repondéré, il retrouve 26,1 % (population 26,2 %). </a:t>
+            </a:r>
+            <a:pPr indent="0" marL="0">
+              <a:buNone/>
+            </a:pPr>
+            <a:r>
+              <a:rPr lang="en-US" sz="1200" b="1" dirty="0">
                 <a:solidFill>
                   <a:srgbClr val="14213D"/>
                 </a:solidFill>
@@ -7268,9 +8115,23 @@
                 <a:ea typeface="Calibri" pitchFamily="34" charset="-122"/>
                 <a:cs typeface="Calibri" pitchFamily="34" charset="-120"/>
               </a:rPr>
-              <a:t>Les grappes varient de 18 % à 36 % : les retards dépendent énormément du jour (de 10 % à 63 %). Retenu : stratifié par jour — les 61 jours sont représentés, 26,5 % contre 26,2 % dans la population.</a:t>
-            </a:r>
-            <a:endParaRPr lang="en-US" sz="1300" dirty="0"/>
+              <a:t>Retenu : stratifié par jour </a:t>
+            </a:r>
+            <a:pPr indent="0" marL="0">
+              <a:buNone/>
+            </a:pPr>
+            <a:r>
+              <a:rPr lang="en-US" sz="1200" dirty="0">
+                <a:solidFill>
+                  <a:srgbClr val="1F2937"/>
+                </a:solidFill>
+                <a:latin typeface="Calibri" pitchFamily="34" charset="0"/>
+                <a:ea typeface="Calibri" pitchFamily="34" charset="-122"/>
+                <a:cs typeface="Calibri" pitchFamily="34" charset="-120"/>
+              </a:rPr>
+              <a:t>(groupe de tête, 61 jours représentés).</a:t>
+            </a:r>
+            <a:endParaRPr lang="en-US" sz="1200" dirty="0"/>
           </a:p>
         </p:txBody>
       </p:sp>
@@ -8611,7 +9472,7 @@
                 <a:ea typeface="Calibri" pitchFamily="34" charset="-122"/>
                 <a:cs typeface="Calibri" pitchFamily="34" charset="-120"/>
               </a:rPr>
-              <a:t>Streamlit + Plotly · filtres liés · 5 indicateurs · 5 onglets</a:t>
+              <a:t>Streamlit + Plotly · en ligne sur Streamlit Cloud · filtres liés · 5 indicateurs · 7 onglets</a:t>
             </a:r>
             <a:endParaRPr lang="en-US" sz="1400" dirty="0"/>
           </a:p>
@@ -8805,7 +9666,7 @@
                 <a:ea typeface="Calibri" pitchFamily="34" charset="-122"/>
                 <a:cs typeface="Calibri" pitchFamily="34" charset="-120"/>
               </a:rPr>
-              <a:t>Destinations : survoler Orlando (MCO)</a:t>
+              <a:t>Échantillonnage : choisir Bootstrap → doublons et score en direct</a:t>
             </a:r>
             <a:endParaRPr lang="en-US" sz="1200" dirty="0"/>
           </a:p>

</xml_diff>